<commit_message>
docs: atualiza apresentação para nova versão
Co-Authored-By: Claude Sonnet 4.6 <noreply@anthropic.com>
</commit_message>
<xml_diff>
--- a/docs/Avaliação_Comparativa_de_Estratégias_de_Chunking_em_Documentos_Institucionais_Brasileiros_final.pptx
+++ b/docs/Avaliação_Comparativa_de_Estratégias_de_Chunking_em_Documentos_Institucionais_Brasileiros_final.pptx
@@ -1879,8 +1879,8 @@
         </p:nvSpPr>
         <p:spPr>
           <a:xfrm>
-            <a:off x="557213" y="784501"/>
-            <a:ext cx="8029575" cy="3574498"/>
+            <a:off x="557213" y="764214"/>
+            <a:ext cx="8029575" cy="3615072"/>
           </a:xfrm>
           <a:prstGeom prst="rect">
             <a:avLst/>
@@ -1906,8 +1906,8 @@
         </p:nvSpPr>
         <p:spPr>
           <a:xfrm>
-            <a:off x="1000125" y="1437987"/>
-            <a:ext cx="7143750" cy="1131503"/>
+            <a:off x="1000125" y="1255681"/>
+            <a:ext cx="7143750" cy="1028700"/>
           </a:xfrm>
           <a:prstGeom prst="rect">
             <a:avLst/>
@@ -1923,12 +1923,12 @@
           <a:p>
             <a:pPr algn="ctr" indent="0" marL="0">
               <a:lnSpc>
-                <a:spcPts val="3000"/>
-              </a:lnSpc>
-              <a:buNone/>
-            </a:pPr>
-            <a:r>
-              <a:rPr lang="en-US" sz="2226" b="1" spc="2" kern="0" dirty="0">
+                <a:spcPts val="2700"/>
+              </a:lnSpc>
+              <a:buNone/>
+            </a:pPr>
+            <a:r>
+              <a:rPr lang="en-US" sz="2016" b="1" spc="2" kern="0" dirty="0">
                 <a:solidFill>
                   <a:srgbClr val="00FF41"/>
                 </a:solidFill>
@@ -1938,7 +1938,7 @@
               </a:rPr>
               <a:t>AVALIAÇÃO COMPARATIVA DE ESTRATÉGIAS DE CHUNKING EM DOCUMENTOS INSTITUCIONAIS BRASILEIROS</a:t>
             </a:r>
-            <a:endParaRPr lang="en-US" sz="2226" dirty="0"/>
+            <a:endParaRPr lang="en-US" sz="2016" dirty="0"/>
           </a:p>
         </p:txBody>
       </p:sp>
@@ -1950,8 +1950,8 @@
         </p:nvSpPr>
         <p:spPr>
           <a:xfrm>
-            <a:off x="2759273" y="2883815"/>
-            <a:ext cx="3625453" cy="169664"/>
+            <a:off x="2964656" y="2520125"/>
+            <a:ext cx="3214688" cy="150019"/>
           </a:xfrm>
           <a:prstGeom prst="rect">
             <a:avLst/>
@@ -1967,12 +1967,12 @@
           <a:p>
             <a:pPr algn="ctr" indent="0" marL="0">
               <a:lnSpc>
-                <a:spcPts val="1200"/>
-              </a:lnSpc>
-              <a:buNone/>
-            </a:pPr>
-            <a:r>
-              <a:rPr lang="en-US" sz="942" dirty="0">
+                <a:spcPts val="1100"/>
+              </a:lnSpc>
+              <a:buNone/>
+            </a:pPr>
+            <a:r>
+              <a:rPr lang="en-US" sz="834" dirty="0">
                 <a:solidFill>
                   <a:srgbClr val="FFFFFF"/>
                 </a:solidFill>
@@ -1982,7 +1982,7 @@
               </a:rPr>
               <a:t>Framework RAG para Busca Semântica Inteligente</a:t>
             </a:r>
-            <a:endParaRPr lang="en-US" sz="942" dirty="0"/>
+            <a:endParaRPr lang="en-US" sz="834" dirty="0"/>
           </a:p>
         </p:txBody>
       </p:sp>
@@ -1994,8 +1994,8 @@
         </p:nvSpPr>
         <p:spPr>
           <a:xfrm>
-            <a:off x="1000125" y="3453529"/>
-            <a:ext cx="7143750" cy="169664"/>
+            <a:off x="1000125" y="2955894"/>
+            <a:ext cx="7143750" cy="150019"/>
           </a:xfrm>
           <a:prstGeom prst="rect">
             <a:avLst/>
@@ -2011,12 +2011,12 @@
           <a:p>
             <a:pPr algn="ctr" indent="0" marL="0">
               <a:lnSpc>
-                <a:spcPts val="1200"/>
-              </a:lnSpc>
-              <a:buNone/>
-            </a:pPr>
-            <a:r>
-              <a:rPr lang="en-US" sz="942" dirty="0">
+                <a:spcPts val="1100"/>
+              </a:lnSpc>
+              <a:buNone/>
+            </a:pPr>
+            <a:r>
+              <a:rPr lang="en-US" sz="834" dirty="0">
                 <a:solidFill>
                   <a:srgbClr val="00FF41"/>
                 </a:solidFill>
@@ -2026,7 +2026,7 @@
               </a:rPr>
               <a:t>Equipe 7: Tiago Cardoso Soares &amp; Alan Tulio Lino Gonçalves</a:t>
             </a:r>
-            <a:endParaRPr lang="en-US" sz="942" dirty="0"/>
+            <a:endParaRPr lang="en-US" sz="834" dirty="0"/>
           </a:p>
         </p:txBody>
       </p:sp>
@@ -2038,8 +2038,8 @@
         </p:nvSpPr>
         <p:spPr>
           <a:xfrm>
-            <a:off x="1000125" y="3908943"/>
-            <a:ext cx="7143750" cy="121444"/>
+            <a:off x="2828032" y="3470244"/>
+            <a:ext cx="3487936" cy="123230"/>
           </a:xfrm>
           <a:prstGeom prst="rect">
             <a:avLst/>
@@ -2053,16 +2053,148 @@
           </a:bodyPr>
           <a:lstStyle/>
           <a:p>
+            <a:pPr algn="l" indent="0" marL="0">
+              <a:lnSpc>
+                <a:spcPts val="900"/>
+              </a:lnSpc>
+              <a:buNone/>
+            </a:pPr>
+            <a:r>
+              <a:rPr lang="en-US" sz="674" dirty="0">
+                <a:solidFill>
+                  <a:srgbClr val="FFFFFF"/>
+                </a:solidFill>
+                <a:latin typeface="JetBrains Mono" pitchFamily="34" charset="0"/>
+                <a:ea typeface="JetBrains Mono" pitchFamily="34" charset="-122"/>
+                <a:cs typeface="JetBrains Mono" pitchFamily="34" charset="-120"/>
+              </a:rPr>
+              <a:t>[API/BACKEND]:</a:t>
+            </a:r>
+            <a:r>
+              <a:rPr lang="en-US" sz="674" dirty="0">
+                <a:solidFill>
+                  <a:srgbClr val="888888"/>
+                </a:solidFill>
+                <a:latin typeface="JetBrains Mono" pitchFamily="34" charset="0"/>
+                <a:ea typeface="JetBrains Mono" pitchFamily="34" charset="-122"/>
+                <a:cs typeface="JetBrains Mono" pitchFamily="34" charset="-120"/>
+              </a:rPr>
+              <a:t> </a:t>
+            </a:r>
+            <a:r>
+              <a:rPr lang="en-US" sz="674" dirty="0">
+                <a:solidFill>
+                  <a:srgbClr val="00FF41"/>
+                </a:solidFill>
+                <a:latin typeface="JetBrains Mono" pitchFamily="34" charset="0"/>
+                <a:ea typeface="JetBrains Mono" pitchFamily="34" charset="-122"/>
+                <a:cs typeface="JetBrains Mono" pitchFamily="34" charset="-120"/>
+              </a:rPr>
+              <a:t>github.com/tiagocardosos/api-chunking-evaluation</a:t>
+            </a:r>
+            <a:endParaRPr lang="en-US" sz="674" dirty="0"/>
+          </a:p>
+        </p:txBody>
+      </p:sp>
+      <p:sp>
+        <p:nvSpPr>
+          <p:cNvPr id="8" name="Text 5"/>
+          <p:cNvSpPr/>
+          <p:nvPr/>
+        </p:nvSpPr>
+        <p:spPr>
+          <a:xfrm>
+            <a:off x="2828032" y="3650624"/>
+            <a:ext cx="3487936" cy="123230"/>
+          </a:xfrm>
+          <a:prstGeom prst="rect">
+            <a:avLst/>
+          </a:prstGeom>
+          <a:noFill/>
+          <a:ln/>
+        </p:spPr>
+        <p:txBody>
+          <a:bodyPr wrap="none" lIns="0" tIns="0" rIns="0" bIns="0" rtlCol="0" anchor="t">
+            <a:spAutoFit/>
+          </a:bodyPr>
+          <a:lstStyle/>
+          <a:p>
+            <a:pPr algn="l" indent="0" marL="0">
+              <a:lnSpc>
+                <a:spcPts val="900"/>
+              </a:lnSpc>
+              <a:buNone/>
+            </a:pPr>
+            <a:r>
+              <a:rPr lang="en-US" sz="674" dirty="0">
+                <a:solidFill>
+                  <a:srgbClr val="FFFFFF"/>
+                </a:solidFill>
+                <a:latin typeface="JetBrains Mono" pitchFamily="34" charset="0"/>
+                <a:ea typeface="JetBrains Mono" pitchFamily="34" charset="-122"/>
+                <a:cs typeface="JetBrains Mono" pitchFamily="34" charset="-120"/>
+              </a:rPr>
+              <a:t>[FRONTEND]:</a:t>
+            </a:r>
+            <a:r>
+              <a:rPr lang="en-US" sz="674" dirty="0">
+                <a:solidFill>
+                  <a:srgbClr val="888888"/>
+                </a:solidFill>
+                <a:latin typeface="JetBrains Mono" pitchFamily="34" charset="0"/>
+                <a:ea typeface="JetBrains Mono" pitchFamily="34" charset="-122"/>
+                <a:cs typeface="JetBrains Mono" pitchFamily="34" charset="-120"/>
+              </a:rPr>
+              <a:t> </a:t>
+            </a:r>
+            <a:r>
+              <a:rPr lang="en-US" sz="674" dirty="0">
+                <a:solidFill>
+                  <a:srgbClr val="00FF41"/>
+                </a:solidFill>
+                <a:latin typeface="JetBrains Mono" pitchFamily="34" charset="0"/>
+                <a:ea typeface="JetBrains Mono" pitchFamily="34" charset="-122"/>
+                <a:cs typeface="JetBrains Mono" pitchFamily="34" charset="-120"/>
+              </a:rPr>
+              <a:t>github.com/tiagocardosos/rag-orbit</a:t>
+            </a:r>
+            <a:endParaRPr lang="en-US" sz="674" dirty="0"/>
+          </a:p>
+        </p:txBody>
+      </p:sp>
+      <p:sp>
+        <p:nvSpPr>
+          <p:cNvPr id="9" name="Text 6"/>
+          <p:cNvSpPr/>
+          <p:nvPr/>
+        </p:nvSpPr>
+        <p:spPr>
+          <a:xfrm>
+            <a:off x="1000125" y="4045316"/>
+            <a:ext cx="7143750" cy="105370"/>
+          </a:xfrm>
+          <a:prstGeom prst="rect">
+            <a:avLst/>
+          </a:prstGeom>
+          <a:noFill/>
+          <a:ln/>
+        </p:spPr>
+        <p:txBody>
+          <a:bodyPr wrap="none" lIns="0" tIns="0" rIns="0" bIns="0" rtlCol="0" anchor="t">
+            <a:spAutoFit/>
+          </a:bodyPr>
+          <a:lstStyle/>
+          <a:p>
             <a:pPr algn="ctr" indent="0" marL="0">
               <a:lnSpc>
-                <a:spcPts val="900"/>
-              </a:lnSpc>
-              <a:buNone/>
-            </a:pPr>
-            <a:r>
-              <a:rPr lang="en-US" sz="727" spc="2" kern="0" dirty="0">
-                <a:solidFill>
-                  <a:srgbClr val="888888"/>
+                <a:spcPts val="800"/>
+              </a:lnSpc>
+              <a:buNone/>
+            </a:pPr>
+            <a:r>
+              <a:rPr lang="en-US" sz="621" spc="2" kern="0" dirty="0">
+                <a:solidFill>
+                  <a:srgbClr val="666666"/>
                 </a:solidFill>
                 <a:latin typeface="Inter" pitchFamily="34" charset="0"/>
                 <a:ea typeface="Inter" pitchFamily="34" charset="-122"/>
@@ -2070,7 +2202,7 @@
               </a:rPr>
               <a:t>INTELIGÊNCIA ARTIFICIAL GENERATIVA | PROF. MARCELO RODRIGO DE SOUZA PITA</a:t>
             </a:r>
-            <a:endParaRPr lang="en-US" sz="727" dirty="0"/>
+            <a:endParaRPr lang="en-US" sz="621" dirty="0"/>
           </a:p>
         </p:txBody>
       </p:sp>

</xml_diff>